<commit_message>
M8: budgets to 4,800/5,000 (+~10% again), FINE x0.1 trim thrust, ,/. warp keys in cockpit
- Budgets: GEO 4,400 -> 4,800 m/s (~940 margin, ~25% reserve); Moon 4,600 ->
  5,000 (~1,010). Worksheet 8, instructor guide (+regen), module-8 deck (5 text
  runs) all reconciled; no stale numbers (grep clean).
- New FINE x0.1 thrust toggle on the pad (or hold Shift): 50 m/s-per-second for
  station-keeping / gate-threading; at full rate the shortest tap was ~50 m/s.
  Cockpit tour + cheat sheet updated.
- ',' / '.' time-warp keys now work in the cockpit (scale the auto warp,
  0.125x..8x, reset each flight, current value flashed in the mission banner
  and visible in the console's warp readout).
</commit_message>
<xml_diff>
--- a/slides/module8.pptx
+++ b/slides/module8.pptx
@@ -443,7 +443,7 @@
           <a:lstStyle/>
           <a:p>
             <a:r>
-              <a:t>The warm-up is the Module 4 recipe flown for real: raise apogee, coast, circularize. The second burn surprises students — you crawl into apogee at 1.6 kilometers per second and must nearly double your speed. At 3,860 of 4,400 meters per second, sloppy thruster work fails the mission; victory is holding station near the target for a full orbit, not touching it.</a:t>
+              <a:t>The warm-up is the Module 4 recipe flown for real: raise apogee, coast, circularize. The second burn surprises students — you crawl into apogee at 1.6 kilometers per second and must nearly double your speed. At 3,860 of 4,800 meters per second, sloppy thruster work fails the mission; victory is holding station near the target for a full orbit, not touching it.</a:t>
             </a:r>
           </a:p>
         </p:txBody>
@@ -583,7 +583,7 @@
           <a:lstStyle/>
           <a:p>
             <a:r>
-              <a:t>Lunar orbit insertion is the counter-intuitive finale: after days of speeding up and coasting, the arrival burn is a retrograde brake. The Moon's gravity is too weak to capture a spacecraft at flyby speed — shed about 900 meters per second at closest approach or slingshot past. The full mission budget is 4,600; the logbook shows whether the plan ever fit.</a:t>
+              <a:t>Lunar orbit insertion is the counter-intuitive finale: after days of speeding up and coasting, the arrival burn is a retrograde brake. The Moon's gravity is too weak to capture a spacecraft at flyby speed — shed about 900 meters per second at closest approach or slingshot past. The full mission budget is 5,000; the logbook shows whether the plan ever fit.</a:t>
             </a:r>
           </a:p>
         </p:txBody>
@@ -4583,7 +4583,7 @@
                 </a:solidFill>
                 <a:latin typeface="Arial"/>
               </a:rPr>
-              <a:t>unlocked by a clean GEO run: lead a moving target across 384,400 km.</a:t>
+              <a:t>unlocked by a clean GEO run: lead a moving target across 384,800 km.</a:t>
             </a:r>
           </a:p>
         </p:txBody>
@@ -5164,7 +5164,7 @@
                 </a:solidFill>
                 <a:latin typeface="Arial"/>
               </a:rPr>
-              <a:t>3,860 / 4,400</a:t>
+              <a:t>3,860 / 4,800</a:t>
             </a:r>
           </a:p>
           <a:p>
@@ -6174,7 +6174,7 @@
                 </a:solidFill>
                 <a:latin typeface="Arial"/>
               </a:rPr>
-              <a:t>4,600 m/s</a:t>
+              <a:t>5,000 m/s</a:t>
             </a:r>
           </a:p>
           <a:p>

</xml_diff>

<commit_message>
M8: lunar budget +50% (5,000 -> 7,500); wider ,/. warp authority (x1/16..x16)
- Lunar exercise budget 7,500 m/s (~3,510 margin over the 3,987 reference —
  hand-flying LOI + the lunar circularize is meant to be forgiving). GEO stays
  4,800. Worksheet 8, instructor guide, module-8 deck (4 runs) reconciled;
  stale-number grep clean; synced to workbooks.
- ',' / '.' cockpit warp keys: range widened from x1/8..x8 to x1/16..x16 so
  the effect is unmistakable. (Handler verified present and unobstructed —
  three additive keydown listeners, DEV one gated; if the keys seem dead the
  tab is running pre-update code: hard-refresh.)
</commit_message>
<xml_diff>
--- a/slides/module8.pptx
+++ b/slides/module8.pptx
@@ -513,7 +513,7 @@
           <a:lstStyle/>
           <a:p>
             <a:r>
-              <a:t>Trans-lunar injection is the duck-hunter shot from Module 5 flown with real stakes: the Moon moves roughly 120 degrees during the four-day coast, so you burn toward empty space. Aim the apogee just past the Moon's orbit — about 395,000 kilometers — because a dead-center aim is a collision course. Then you wait, watching the geometry close.</a:t>
+              <a:t>Trans-lunar injection is the duck-hunter shot from Module 5 flown with real stakes: the Moon moves roughly 120 degrees during the four-day coast, so you burn toward empty space. Aim the apogee just past the Moon's orbit — about 397,500 kilometers — because a dead-center aim is a collision course. Then you wait, watching the geometry close.</a:t>
             </a:r>
           </a:p>
         </p:txBody>
@@ -583,7 +583,7 @@
           <a:lstStyle/>
           <a:p>
             <a:r>
-              <a:t>Lunar orbit insertion is the counter-intuitive finale: after days of speeding up and coasting, the arrival burn is a retrograde brake. The Moon's gravity is too weak to capture a spacecraft at flyby speed — shed about 900 meters per second at closest approach or slingshot past. The full mission budget is 5,000; the logbook shows whether the plan ever fit.</a:t>
+              <a:t>Lunar orbit insertion is the counter-intuitive finale: after days of speeding up and coasting, the arrival burn is a retrograde brake. The Moon's gravity is too weak to capture a spacecraft at flyby speed — shed about 900 meters per second at closest approach or slingshot past. The full mission budget is 7,500; the logbook shows whether the plan ever fit.</a:t>
             </a:r>
           </a:p>
         </p:txBody>
@@ -5739,7 +5739,7 @@
                 </a:solidFill>
                 <a:latin typeface="Arial"/>
               </a:rPr>
-              <a:t>Aim for ~395,000 km — dead-center on the Moon is a collision, not a capture.</a:t>
+              <a:t>Aim for ~397,500 km — dead-center on the Moon is a collision, not a capture.</a:t>
             </a:r>
           </a:p>
         </p:txBody>
@@ -6174,7 +6174,7 @@
                 </a:solidFill>
                 <a:latin typeface="Arial"/>
               </a:rPr>
-              <a:t>5,000 m/s</a:t>
+              <a:t>7,500 m/s</a:t>
             </a:r>
           </a:p>
           <a:p>

</xml_diff>